<commit_message>
Deploy hub update for Giuliano Cisneros
</commit_message>
<xml_diff>
--- a/webinar/giuliano-cisneros-webinar-deck.pptx
+++ b/webinar/giuliano-cisneros-webinar-deck.pptx
@@ -2763,6 +2763,10 @@
           </a:solidFill>
           <a:ln/>
         </p:spPr>
+        <p:txBody>
+          <a:bodyPr/>
+          <a:p/>
+        </p:txBody>
       </p:sp>
       <p:sp>
         <p:nvSpPr>
@@ -3377,6 +3381,10 @@
           </a:solidFill>
           <a:ln/>
         </p:spPr>
+        <p:txBody>
+          <a:bodyPr/>
+          <a:p/>
+        </p:txBody>
       </p:sp>
       <p:sp>
         <p:nvSpPr>
@@ -3514,6 +3522,10 @@
           </a:solidFill>
           <a:ln/>
         </p:spPr>
+        <p:txBody>
+          <a:bodyPr/>
+          <a:p/>
+        </p:txBody>
       </p:sp>
       <p:sp>
         <p:nvSpPr>
@@ -3651,6 +3663,10 @@
           </a:solidFill>
           <a:ln/>
         </p:spPr>
+        <p:txBody>
+          <a:bodyPr/>
+          <a:p/>
+        </p:txBody>
       </p:sp>
       <p:sp>
         <p:nvSpPr>
@@ -3788,6 +3804,10 @@
           </a:solidFill>
           <a:ln/>
         </p:spPr>
+        <p:txBody>
+          <a:bodyPr/>
+          <a:p/>
+        </p:txBody>
       </p:sp>
       <p:sp>
         <p:nvSpPr>
@@ -4088,7 +4108,7 @@
                 <a:ea typeface="Arial" pitchFamily="34" charset="-122"/>
                 <a:cs typeface="Arial" pitchFamily="34" charset="-120"/>
               </a:rPr>
-              <a:t>"Era tímido y cerró siguiendo el script"</a:t>
+              <a:t>Juan Pablo Vallejo · $10,800 al mes</a:t>
             </a:r>
             <a:endParaRPr lang="en-US" sz="3000" dirty="0"/>
           </a:p>
@@ -4127,7 +4147,7 @@
                 <a:ea typeface="Arial" pitchFamily="34" charset="-122"/>
                 <a:cs typeface="Arial" pitchFamily="34" charset="-120"/>
               </a:rPr>
-              <a:t>No tenía labia ni experiencia. Siguió el guion al pie de la letra en su primera llamada. La habilidad llegó después. El cierre llegó primero.</a:t>
+              <a:t>Alumno del modelo Haztuagencia. Hoy factura $10,800 al mes vendiendo servicios a negocios. Su testimonio completo está grabado en video.</a:t>
             </a:r>
             <a:endParaRPr lang="en-US" sz="1700" dirty="0"/>
           </a:p>
@@ -4647,6 +4667,10 @@
           </a:solidFill>
           <a:ln/>
         </p:spPr>
+        <p:txBody>
+          <a:bodyPr/>
+          <a:p/>
+        </p:txBody>
       </p:sp>
       <p:sp>
         <p:nvSpPr>
@@ -4936,7 +4960,7 @@
                 <a:ea typeface="Arial" pitchFamily="34" charset="-122"/>
                 <a:cs typeface="Arial" pitchFamily="34" charset="-120"/>
               </a:rPr>
-              <a:t>"Cerró su primer cliente sin una sola publicación"</a:t>
+              <a:t>Dayanne Rojas · $9,000 al mes</a:t>
             </a:r>
             <a:endParaRPr lang="en-US" sz="3000" dirty="0"/>
           </a:p>
@@ -4975,7 +4999,7 @@
                 <a:ea typeface="Arial" pitchFamily="34" charset="-122"/>
                 <a:cs typeface="Arial" pitchFamily="34" charset="-120"/>
               </a:rPr>
-              <a:t>Cero seguidores, cero contenido. Solo prospección directa con el mensaje correcto. El primer cliente no vino de una audiencia. Vino de una lista.</a:t>
+              <a:t>Alumna del modelo Haztuagencia. Hoy factura $9,000 al mes vendiendo servicios a negocios. Su testimonio completo está grabado en video.</a:t>
             </a:r>
             <a:endParaRPr lang="en-US" sz="1700" dirty="0"/>
           </a:p>
@@ -5780,7 +5804,7 @@
                 <a:ea typeface="Arial" pitchFamily="34" charset="-122"/>
                 <a:cs typeface="Arial" pitchFamily="34" charset="-120"/>
               </a:rPr>
-              <a:t>Comunidad activa de alumnos que ya cerraron</a:t>
+              <a:t>Comunidad activa: Rubén, Juan Pablo, Dayanne y más resultados en video</a:t>
             </a:r>
             <a:endParaRPr lang="en-US" sz="1600" dirty="0"/>
           </a:p>
@@ -6151,6 +6175,10 @@
           </a:solidFill>
           <a:ln/>
         </p:spPr>
+        <p:txBody>
+          <a:bodyPr/>
+          <a:p/>
+        </p:txBody>
       </p:sp>
       <p:sp>
         <p:nvSpPr>
@@ -6290,6 +6318,10 @@
           </a:solidFill>
           <a:ln/>
         </p:spPr>
+        <p:txBody>
+          <a:bodyPr/>
+          <a:p/>
+        </p:txBody>
       </p:sp>
       <p:sp>
         <p:nvSpPr>
@@ -6583,6 +6615,10 @@
             <a:prstDash val="solid"/>
           </a:ln>
         </p:spPr>
+        <p:txBody>
+          <a:bodyPr/>
+          <a:p/>
+        </p:txBody>
       </p:sp>
       <p:sp>
         <p:nvSpPr>
@@ -6695,7 +6731,7 @@
                 <a:ea typeface="Arial" pitchFamily="34" charset="-122"/>
                 <a:cs typeface="Arial" pitchFamily="34" charset="-120"/>
               </a:rPr>
-              <a:t>Garantía: si haces el trabajo y sigues el sistema, tienes el respaldo del grupo en cada paso.</a:t>
+              <a:t>Garantía: si haces el trabajo y sigues el sistema, tienes el respaldo del grupo en cada paso. El grupo de Jerónimo ($8,000/mes), Leonardo ($6,000/mes) y David ($3,250/mes).</a:t>
             </a:r>
             <a:endParaRPr lang="en-US" sz="1500" dirty="0"/>
           </a:p>
@@ -6910,6 +6946,10 @@
           </a:solidFill>
           <a:ln/>
         </p:spPr>
+        <p:txBody>
+          <a:bodyPr/>
+          <a:p/>
+        </p:txBody>
       </p:sp>
       <p:sp>
         <p:nvSpPr>
@@ -6930,6 +6970,10 @@
           </a:solidFill>
           <a:ln/>
         </p:spPr>
+        <p:txBody>
+          <a:bodyPr/>
+          <a:p/>
+        </p:txBody>
       </p:sp>
       <p:sp>
         <p:nvSpPr>
@@ -7069,6 +7113,10 @@
           </a:solidFill>
           <a:ln/>
         </p:spPr>
+        <p:txBody>
+          <a:bodyPr/>
+          <a:p/>
+        </p:txBody>
       </p:sp>
       <p:sp>
         <p:nvSpPr>
@@ -7089,6 +7137,10 @@
           </a:solidFill>
           <a:ln/>
         </p:spPr>
+        <p:txBody>
+          <a:bodyPr/>
+          <a:p/>
+        </p:txBody>
       </p:sp>
       <p:sp>
         <p:nvSpPr>
@@ -7228,6 +7280,10 @@
           </a:solidFill>
           <a:ln/>
         </p:spPr>
+        <p:txBody>
+          <a:bodyPr/>
+          <a:p/>
+        </p:txBody>
       </p:sp>
       <p:sp>
         <p:nvSpPr>
@@ -7248,6 +7304,10 @@
           </a:solidFill>
           <a:ln/>
         </p:spPr>
+        <p:txBody>
+          <a:bodyPr/>
+          <a:p/>
+        </p:txBody>
       </p:sp>
       <p:sp>
         <p:nvSpPr>
@@ -7575,6 +7635,10 @@
           </a:solidFill>
           <a:ln/>
         </p:spPr>
+        <p:txBody>
+          <a:bodyPr/>
+          <a:p/>
+        </p:txBody>
       </p:sp>
       <p:sp>
         <p:nvSpPr>
@@ -7675,6 +7739,10 @@
           </a:solidFill>
           <a:ln/>
         </p:spPr>
+        <p:txBody>
+          <a:bodyPr/>
+          <a:p/>
+        </p:txBody>
       </p:sp>
       <p:sp>
         <p:nvSpPr>
@@ -7883,6 +7951,10 @@
           </a:solidFill>
           <a:ln/>
         </p:spPr>
+        <p:txBody>
+          <a:bodyPr/>
+          <a:p/>
+        </p:txBody>
       </p:sp>
       <p:sp>
         <p:nvSpPr>
@@ -7983,6 +8055,10 @@
           </a:solidFill>
           <a:ln/>
         </p:spPr>
+        <p:txBody>
+          <a:bodyPr/>
+          <a:p/>
+        </p:txBody>
       </p:sp>
       <p:sp>
         <p:nvSpPr>
@@ -8386,6 +8462,10 @@
             <a:prstDash val="solid"/>
           </a:ln>
         </p:spPr>
+        <p:txBody>
+          <a:bodyPr/>
+          <a:p/>
+        </p:txBody>
       </p:sp>
       <p:sp>
         <p:nvSpPr>
@@ -8683,7 +8763,7 @@
                 <a:ea typeface="Arial" pitchFamily="34" charset="-122"/>
                 <a:cs typeface="Arial" pitchFamily="34" charset="-120"/>
               </a:rPr>
-              <a:t>De un empleo sin rumbo a $70,000 en un mes</a:t>
+              <a:t>De un empleo sin rumbo a $80,000 en un mes</a:t>
             </a:r>
             <a:endParaRPr lang="en-US" sz="4000" dirty="0"/>
           </a:p>
@@ -8935,6 +9015,10 @@
           </a:solidFill>
           <a:ln/>
         </p:spPr>
+        <p:txBody>
+          <a:bodyPr/>
+          <a:p/>
+        </p:txBody>
       </p:sp>
       <p:sp>
         <p:nvSpPr>
@@ -8994,6 +9078,10 @@
           </a:solidFill>
           <a:ln/>
         </p:spPr>
+        <p:txBody>
+          <a:bodyPr/>
+          <a:p/>
+        </p:txBody>
       </p:sp>
       <p:sp>
         <p:nvSpPr>
@@ -9053,6 +9141,10 @@
           </a:solidFill>
           <a:ln/>
         </p:spPr>
+        <p:txBody>
+          <a:bodyPr/>
+          <a:p/>
+        </p:txBody>
       </p:sp>
       <p:sp>
         <p:nvSpPr>
@@ -9112,6 +9204,10 @@
           </a:solidFill>
           <a:ln/>
         </p:spPr>
+        <p:txBody>
+          <a:bodyPr/>
+          <a:p/>
+        </p:txBody>
       </p:sp>
       <p:sp>
         <p:nvSpPr>
@@ -9171,6 +9267,10 @@
           </a:solidFill>
           <a:ln/>
         </p:spPr>
+        <p:txBody>
+          <a:bodyPr/>
+          <a:p/>
+        </p:txBody>
       </p:sp>
       <p:sp>
         <p:nvSpPr>
@@ -9205,7 +9305,7 @@
                 <a:ea typeface="Arial" pitchFamily="34" charset="-122"/>
                 <a:cs typeface="Arial" pitchFamily="34" charset="-120"/>
               </a:rPr>
-              <a:t>Hoy facturo más de $70,000 en un mes y entrené a 300+ latinos en USA para hacer lo mismo.</a:t>
+              <a:t>Hoy facturo más de $80,000 en un mes y entrené a 350+ latinos en USA para hacer lo mismo.</a:t>
             </a:r>
             <a:endParaRPr lang="en-US" sz="1600" dirty="0"/>
           </a:p>
@@ -9952,6 +10052,10 @@
           </a:solidFill>
           <a:ln/>
         </p:spPr>
+        <p:txBody>
+          <a:bodyPr/>
+          <a:p/>
+        </p:txBody>
       </p:sp>
       <p:sp>
         <p:nvSpPr>
@@ -10091,6 +10195,10 @@
           </a:solidFill>
           <a:ln/>
         </p:spPr>
+        <p:txBody>
+          <a:bodyPr/>
+          <a:p/>
+        </p:txBody>
       </p:sp>
       <p:sp>
         <p:nvSpPr>
@@ -10230,6 +10338,10 @@
           </a:solidFill>
           <a:ln/>
         </p:spPr>
+        <p:txBody>
+          <a:bodyPr/>
+          <a:p/>
+        </p:txBody>
       </p:sp>
       <p:sp>
         <p:nvSpPr>
@@ -10530,7 +10642,7 @@
                 <a:ea typeface="Arial" pitchFamily="34" charset="-122"/>
                 <a:cs typeface="Arial" pitchFamily="34" charset="-120"/>
               </a:rPr>
-              <a:t>"Eligió un solo servicio y cerró en semanas"</a:t>
+              <a:t>Rubén Hernández · $15,000 al mes</a:t>
             </a:r>
             <a:endParaRPr lang="en-US" sz="3000" dirty="0"/>
           </a:p>
@@ -10569,7 +10681,7 @@
                 <a:ea typeface="Arial" pitchFamily="34" charset="-122"/>
                 <a:cs typeface="Arial" pitchFamily="34" charset="-120"/>
               </a:rPr>
-              <a:t>Un alumno dejó de querer venderlo todo. Se enfocó en un servicio que el negocio ya pagaba. Cerró su primer cliente en cuestión de semanas.</a:t>
+              <a:t>Alumno del modelo Haztuagencia. Hoy factura $15,000 al mes vendiendo servicios a negocios. Su testimonio completo está grabado en video.</a:t>
             </a:r>
             <a:endParaRPr lang="en-US" sz="1700" dirty="0"/>
           </a:p>

</xml_diff>